<commit_message>
Ship demo APK polish: pairing, signal history, map-in-loop, and console replay.
Checkpoint the working demo branch before the white-map / 6-digit pairing / Drive declutter pass.

Co-authored-by: Cursor <cursoragent@cursor.com>
</commit_message>
<xml_diff>
--- a/final_demo_pitch/ppt_assets/COAST_SIH2026_IDEA.pptx
+++ b/final_demo_pitch/ppt_assets/COAST_SIH2026_IDEA.pptx
@@ -5757,7 +5757,7 @@
                   <a:srgbClr val="0B1220"/>
                 </a:solidFill>
               </a:rPr>
-              <a:t>TEAM ID</a:t>
+              <a:t>TBD</a:t>
             </a:r>
           </a:p>
           <a:p>
@@ -5780,7 +5780,7 @@
                   <a:srgbClr val="0B1220"/>
                 </a:solidFill>
               </a:rPr>
-              <a:t>TEAM NAME</a:t>
+              <a:t>COAST</a:t>
             </a:r>
           </a:p>
         </p:txBody>
@@ -6050,7 +6050,7 @@
                   <a:srgbClr val="FFFFFF"/>
                 </a:solidFill>
               </a:rPr>
-              <a:t>TEAM NAME</a:t>
+              <a:t>COAST</a:t>
             </a:r>
             <a:endParaRPr lang="en-IN" dirty="0"/>
           </a:p>
@@ -6714,7 +6714,7 @@
                   <a:srgbClr val="FFFFFF"/>
                 </a:solidFill>
               </a:rPr>
-              <a:t>TEAM NAME</a:t>
+              <a:t>COAST</a:t>
             </a:r>
             <a:endParaRPr lang="en-IN" dirty="0"/>
           </a:p>
@@ -7451,7 +7451,7 @@
                   <a:srgbClr val="FFFFFF"/>
                 </a:solidFill>
               </a:rPr>
-              <a:t>TEAM NAME</a:t>
+              <a:t>COAST</a:t>
             </a:r>
             <a:endParaRPr lang="en-IN" dirty="0"/>
           </a:p>
@@ -7930,7 +7930,7 @@
                   <a:srgbClr val="2B3645"/>
                 </a:solidFill>
               </a:rPr>
-              <a:t>We are at 16.8% against a 27.6% baseline — roughly half the gap closed, with a measured route to the rest.</a:t>
+              <a:t>We are at 16.77% against a 27.58% baseline — roughly half the gap closed, with a measured route to the rest.</a:t>
             </a:r>
           </a:p>
           <a:p>
@@ -8307,7 +8307,7 @@
                   <a:srgbClr val="FFFFFF"/>
                 </a:solidFill>
               </a:rPr>
-              <a:t>TEAM NAME</a:t>
+              <a:t>COAST</a:t>
             </a:r>
             <a:endParaRPr lang="en-IN" dirty="0"/>
           </a:p>
@@ -9259,7 +9259,7 @@
                   <a:srgbClr val="FFFFFF"/>
                 </a:solidFill>
               </a:rPr>
-              <a:t>TEAM NAME</a:t>
+              <a:t>COAST</a:t>
             </a:r>
             <a:endParaRPr lang="en-IN" dirty="0"/>
           </a:p>
@@ -9652,7 +9652,7 @@
                   <a:srgbClr val="008A72"/>
                 </a:solidFill>
               </a:rPr>
-              <a:t>27.6% → 16.8%</a:t>
+              <a:t>27.58% → 16.77%</a:t>
             </a:r>
           </a:p>
           <a:p>
@@ -9678,7 +9678,7 @@
                   <a:srgbClr val="008A72"/>
                 </a:solidFill>
               </a:rPr>
-              <a:t>16.9% → 7.2%</a:t>
+              <a:t>16.87% → 7.22%</a:t>
             </a:r>
           </a:p>
           <a:p>

</xml_diff>